<commit_message>
Clarify charging comparison scope in final weekly artifacts
</commit_message>
<xml_diff>
--- a/outputs/week_20260921/slides/weekly_deck.pptx
+++ b/outputs/week_20260921/slides/weekly_deck.pptx
@@ -7935,7 +7935,7 @@
             </a:pPr>
             <a:r>
               <a:rPr lang="en"/>
-              <a:t>Saved trip sequences recharged; no fresh CG under this physics.</a:t>
+              <a:t>Saved sequences differ: not fresh CG or a fee-only causal test.</a:t>
             </a:r>
             <a:endParaRPr/>
           </a:p>
@@ -8057,7 +8057,7 @@
             </a:pPr>
             <a:r>
               <a:rPr lang="en"/>
-              <a:t>Matched k=5: fewer starts with a start fee</a:t>
+              <a:t>Matched k=5: charging costs and session counts</a:t>
             </a:r>
             <a:endParaRPr/>
           </a:p>
@@ -8078,7 +8078,7 @@
             <a:tbl>
               <a:tblPr>
                 <a:noFill/>
-                <a:tableStyleId>{F2593195-F5E5-4433-85D5-9C2DE3BCE9B8}</a:tableStyleId>
+                <a:tableStyleId>{BEF250BF-79D3-451D-8867-9F2858C5553F}</a:tableStyleId>
               </a:tblPr>
               <a:tblGrid>
                 <a:gridCol w="1447800"/>
@@ -9137,7 +9137,7 @@
             <a:tbl>
               <a:tblPr>
                 <a:noFill/>
-                <a:tableStyleId>{F2593195-F5E5-4433-85D5-9C2DE3BCE9B8}</a:tableStyleId>
+                <a:tableStyleId>{BEF250BF-79D3-451D-8867-9F2858C5553F}</a:tableStyleId>
               </a:tblPr>
               <a:tblGrid>
                 <a:gridCol w="1447800"/>
@@ -10762,7 +10762,7 @@
             <a:tbl>
               <a:tblPr>
                 <a:noFill/>
-                <a:tableStyleId>{F2593195-F5E5-4433-85D5-9C2DE3BCE9B8}</a:tableStyleId>
+                <a:tableStyleId>{BEF250BF-79D3-451D-8867-9F2858C5553F}</a:tableStyleId>
               </a:tblPr>
               <a:tblGrid>
                 <a:gridCol w="1809750"/>
@@ -11427,7 +11427,7 @@
             <a:tbl>
               <a:tblPr>
                 <a:noFill/>
-                <a:tableStyleId>{F2593195-F5E5-4433-85D5-9C2DE3BCE9B8}</a:tableStyleId>
+                <a:tableStyleId>{BEF250BF-79D3-451D-8867-9F2858C5553F}</a:tableStyleId>
               </a:tblPr>
               <a:tblGrid>
                 <a:gridCol w="1809750"/>

</xml_diff>